<commit_message>
Fix ITEM tag shapes and image swap direction in slide_6d
Co-Authored-By: Claude Sonnet 5 <noreply@anthropic.com>
Claude-Session: https://claude.ai/code/session_01E9QvuhBZminJvrtKVH8YY8
</commit_message>
<xml_diff>
--- a/svetlana/outputs/2026-08-27-slide_6d-edited.pptx
+++ b/svetlana/outputs/2026-08-27-slide_6d-edited.pptx
@@ -4542,6 +4542,75 @@
           </a:prstGeom>
         </p:spPr>
       </p:pic>
+      <p:pic>
+        <p:nvPicPr>
+          <p:cNvPr id="4" name="Product hallux">
+            <a:extLst>
+              <a:ext uri="{FF2B5EF4-FFF2-40B4-BE49-F238E27FC236}">
+                <a16:creationId xmlns:a16="http://schemas.microsoft.com/office/drawing/2014/main" id="{E6384308-90B9-F3DF-6015-59890171478A}"/>
+              </a:ext>
+            </a:extLst>
+          </p:cNvPr>
+          <p:cNvPicPr>
+            <a:picLocks noChangeAspect="1"/>
+          </p:cNvPicPr>
+          <p:nvPr/>
+        </p:nvPicPr>
+        <p:blipFill>
+          <a:blip r:embed="rId3"/>
+          <a:stretch>
+            <a:fillRect/>
+          </a:stretch>
+        </p:blipFill>
+        <p:spPr>
+          <a:xfrm>
+            <a:off x="7068169" y="2707130"/>
+            <a:ext cx="2227147" cy="1675601"/>
+          </a:xfrm>
+          <a:prstGeom prst="rect">
+            <a:avLst/>
+          </a:prstGeom>
+        </p:spPr>
+      </p:pic>
+      <p:cxnSp>
+        <p:nvCxnSpPr>
+          <p:cNvPr id="6" name="מחבר חץ ישר 5">
+            <a:extLst>
+              <a:ext uri="{FF2B5EF4-FFF2-40B4-BE49-F238E27FC236}">
+                <a16:creationId xmlns:a16="http://schemas.microsoft.com/office/drawing/2014/main" id="{14A5F4B8-02F3-C508-9EBD-B8495FF416AA}"/>
+              </a:ext>
+            </a:extLst>
+          </p:cNvPr>
+          <p:cNvCxnSpPr/>
+          <p:nvPr/>
+        </p:nvCxnSpPr>
+        <p:spPr>
+          <a:xfrm>
+            <a:off x="3099816" y="2176272"/>
+            <a:ext cx="3566160" cy="1368658"/>
+          </a:xfrm>
+          <a:prstGeom prst="straightConnector1">
+            <a:avLst/>
+          </a:prstGeom>
+          <a:ln>
+            <a:tailEnd type="triangle"/>
+          </a:ln>
+        </p:spPr>
+        <p:style>
+          <a:lnRef idx="1">
+            <a:schemeClr val="accent1"/>
+          </a:lnRef>
+          <a:fillRef idx="0">
+            <a:schemeClr val="accent1"/>
+          </a:fillRef>
+          <a:effectRef idx="0">
+            <a:schemeClr val="accent1"/>
+          </a:effectRef>
+          <a:fontRef idx="minor">
+            <a:schemeClr val="tx1"/>
+          </a:fontRef>
+        </p:style>
+      </p:cxnSp>
     </p:spTree>
     <p:extLst>
       <p:ext uri="{BB962C8B-B14F-4D97-AF65-F5344CB8AC3E}">

</xml_diff>